<commit_message>
Alinear plantillas de historias con la guia de contenido
Las tres plantillas ahora corresponden a las piezas 8, 9 y 10 de la
guia: Hoy abrimos, Promo del dia y Reserva tu privado, cada una con
la foto de fondo indicada en la guia y sus campos editables.

Co-Authored-By: Claude Fable 5 <noreply@anthropic.com>
Claude-Session: https://claude.ai/code/session_01KpH8oR29wiBhy4iSar9w76
</commit_message>
<xml_diff>
--- a/extravagance/Plantillas_Historias_Extravagance.pptx
+++ b/extravagance/Plantillas_Historias_Extravagance.pptx
@@ -504,7 +504,7 @@
           <a:p>
             <a:r>
               <a:rPr lang="en-US" dirty="0"/>
-              <a:t>PLANTILLA 1 - LA PROMO DE HOY. Editable: nombre de botella, precio antes, precio hoy, vigencia. Sustituir la zona punteada por foto de botella/hielera. Publicar como historia 9:16 con sticker de link a WhatsApp.</a:t>
+              <a:t>PLANTILLA 8 - HOY ABRIMOS. Editable: dia, horario y evento/DJ de la noche. Fondo: foto del venue iluminado (Post 5). Publicar con sticker de enlace a WhatsApp. Se publica cada dia de apertura.</a:t>
             </a:r>
             <a:endParaRPr lang="en-US" dirty="0"/>
           </a:p>
@@ -592,7 +592,7 @@
           <a:p>
             <a:r>
               <a:rPr lang="en-US" dirty="0"/>
-              <a:t>PLANTILLA 2 - COMBO DEL FIN. Editable: los 3 elementos del combo y el precio. Sustituir la zona punteada por foto de mesa VIP. Agregar sticker de link a WhatsApp al publicar.</a:t>
+              <a:t>PLANTILLA 9 - PROMO DEL DIA. Editable: nombre de la promo, que incluye, precio antes, precio hoy y vigencia. Fondo: foto de botella o coctel (Video 3 / Post 6). Si no hay precio anterior, borrar el bloque ANTES y centrar el precio.</a:t>
             </a:r>
             <a:endParaRPr lang="en-US" dirty="0"/>
           </a:p>
@@ -680,7 +680,7 @@
           <a:p>
             <a:r>
               <a:rPr lang="en-US" dirty="0"/>
-              <a:t>PLANTILLA 3 - ULTIMOS PRIVADOS. Editable: numero de privados disponibles y el dia. Sustituir la zona punteada por foto del privado. Publicar con sticker de link a WhatsApp; funciona mejor jueves y viernes.</a:t>
+              <a:t>PLANTILLA 10 - RESERVA TU PRIVADO. Editable: numero de privados disponibles y dia/fecha. Fondo: interior del privado (Post 7). Funciona mejor publicada jueves y viernes, con sticker de enlace a WhatsApp.</a:t>
             </a:r>
             <a:endParaRPr lang="en-US" dirty="0"/>
           </a:p>
@@ -1140,7 +1140,7 @@
         <p:spPr>
           <a:xfrm>
             <a:off x="0" y="1051560"/>
-            <a:ext cx="6858000" cy="5669280"/>
+            <a:ext cx="6858000" cy="5852160"/>
           </a:xfrm>
           <a:prstGeom prst="rect">
             <a:avLst/>
@@ -1164,8 +1164,8 @@
         </p:nvSpPr>
         <p:spPr>
           <a:xfrm>
-            <a:off x="731520" y="3566160"/>
-            <a:ext cx="5394960" cy="640080"/>
+            <a:off x="731520" y="3611880"/>
+            <a:ext cx="5394960" cy="731520"/>
           </a:xfrm>
           <a:prstGeom prst="rect">
             <a:avLst/>
@@ -1189,7 +1189,7 @@
                 <a:ea typeface="Calibri" pitchFamily="34" charset="-122"/>
                 <a:cs typeface="Calibri" pitchFamily="34" charset="-120"/>
               </a:rPr>
-              <a:t>INSERTA AQUÍ tu foto de botella / hielera</a:t>
+              <a:t>INSERTA AQUÍ la foto del venue iluminado</a:t>
             </a:r>
             <a:endParaRPr lang="en-US" sz="1200" dirty="0"/>
           </a:p>
@@ -1206,7 +1206,7 @@
                 <a:ea typeface="Calibri" pitchFamily="34" charset="-122"/>
                 <a:cs typeface="Calibri" pitchFamily="34" charset="-120"/>
               </a:rPr>
-              <a:t>(Insertar › Imagen › enviar al fondo)</a:t>
+              <a:t>(sale del POST 5 — foto hero)</a:t>
             </a:r>
             <a:endParaRPr lang="en-US" sz="1200" dirty="0"/>
           </a:p>
@@ -1220,7 +1220,7 @@
         </p:nvSpPr>
         <p:spPr>
           <a:xfrm>
-            <a:off x="548640" y="7178040"/>
+            <a:off x="548640" y="7388352"/>
             <a:ext cx="201168" cy="201168"/>
           </a:xfrm>
           <a:prstGeom prst="diamond">
@@ -1245,8 +1245,8 @@
         </p:nvSpPr>
         <p:spPr>
           <a:xfrm>
-            <a:off x="914400" y="7150608"/>
-            <a:ext cx="4572000" cy="274320"/>
+            <a:off x="914400" y="7360920"/>
+            <a:ext cx="5029200" cy="274320"/>
           </a:xfrm>
           <a:prstGeom prst="rect">
             <a:avLst/>
@@ -1270,7 +1270,7 @@
                 <a:ea typeface="Calibri" pitchFamily="34" charset="-122"/>
                 <a:cs typeface="Calibri" pitchFamily="34" charset="-120"/>
               </a:rPr>
-              <a:t>P R O M O   D E   H O Y</a:t>
+              <a:t>E S T A   N O C H E</a:t>
             </a:r>
             <a:endParaRPr lang="en-US" sz="1200" dirty="0"/>
           </a:p>
@@ -1284,8 +1284,8 @@
         </p:nvSpPr>
         <p:spPr>
           <a:xfrm>
-            <a:off x="548640" y="7589520"/>
-            <a:ext cx="5760720" cy="822960"/>
+            <a:off x="548640" y="7772400"/>
+            <a:ext cx="5760720" cy="914400"/>
           </a:xfrm>
           <a:prstGeom prst="rect">
             <a:avLst/>
@@ -1301,7 +1301,7 @@
               <a:buNone/>
             </a:pPr>
             <a:r>
-              <a:rPr lang="en-US" sz="4000" b="1" dirty="0">
+              <a:rPr lang="en-US" sz="4600" b="1" dirty="0">
                 <a:solidFill>
                   <a:srgbClr val="FFFFFF"/>
                 </a:solidFill>
@@ -1309,73 +1309,34 @@
                 <a:ea typeface="Calibri" pitchFamily="34" charset="-122"/>
                 <a:cs typeface="Calibri" pitchFamily="34" charset="-120"/>
               </a:rPr>
-              <a:t>BOTELLA DEL MES</a:t>
-            </a:r>
-            <a:endParaRPr lang="en-US" sz="4000" dirty="0"/>
-          </a:p>
-        </p:txBody>
-      </p:sp>
-      <p:sp>
-        <p:nvSpPr>
-          <p:cNvPr id="9" name="Text 7"/>
-          <p:cNvSpPr/>
-          <p:nvPr/>
-        </p:nvSpPr>
-        <p:spPr>
-          <a:xfrm>
-            <a:off x="548640" y="8366760"/>
-            <a:ext cx="5760720" cy="411480"/>
-          </a:xfrm>
-          <a:prstGeom prst="rect">
-            <a:avLst/>
-          </a:prstGeom>
-          <a:noFill/>
-          <a:ln/>
-        </p:spPr>
-        <p:txBody>
-          <a:bodyPr wrap="square" lIns="0" tIns="0" rIns="0" bIns="0" rtlCol="0" anchor="ctr"/>
-          <a:lstStyle/>
-          <a:p>
-            <a:pPr indent="0" marL="0">
-              <a:buNone/>
-            </a:pPr>
-            <a:r>
-              <a:rPr lang="en-US" sz="1800" dirty="0">
-                <a:solidFill>
-                  <a:srgbClr val="D9DDEE"/>
-                </a:solidFill>
-                <a:latin typeface="Calibri" pitchFamily="34" charset="0"/>
-                <a:ea typeface="Calibri" pitchFamily="34" charset="-122"/>
-                <a:cs typeface="Calibri" pitchFamily="34" charset="-120"/>
-              </a:rPr>
-              <a:t>[Nombre de la botella]</a:t>
-            </a:r>
-            <a:endParaRPr lang="en-US" sz="1800" dirty="0"/>
-          </a:p>
-        </p:txBody>
-      </p:sp>
-      <p:sp>
-        <p:nvSpPr>
-          <p:cNvPr id="10" name="Shape 8"/>
-          <p:cNvSpPr/>
-          <p:nvPr/>
-        </p:nvSpPr>
-        <p:spPr>
-          <a:xfrm>
-            <a:off x="548640" y="9052560"/>
-            <a:ext cx="5760720" cy="1600200"/>
+              <a:t>HOY ABRIMOS</a:t>
+            </a:r>
+            <a:endParaRPr lang="en-US" sz="4600" dirty="0"/>
+          </a:p>
+        </p:txBody>
+      </p:sp>
+      <p:sp>
+        <p:nvSpPr>
+          <p:cNvPr id="9" name="Shape 7"/>
+          <p:cNvSpPr/>
+          <p:nvPr/>
+        </p:nvSpPr>
+        <p:spPr>
+          <a:xfrm>
+            <a:off x="548640" y="8732520"/>
+            <a:ext cx="5760720" cy="640080"/>
           </a:xfrm>
           <a:prstGeom prst="roundRect">
             <a:avLst>
-              <a:gd name="adj" fmla="val 6857"/>
+              <a:gd name="adj" fmla="val 14286"/>
             </a:avLst>
           </a:prstGeom>
           <a:solidFill>
             <a:srgbClr val="2C3050"/>
           </a:solidFill>
-          <a:ln w="19050">
+          <a:ln w="12700">
             <a:solidFill>
-              <a:srgbClr val="009CFF"/>
+              <a:srgbClr val="2C3050"/>
             </a:solidFill>
             <a:prstDash val="solid"/>
           </a:ln>
@@ -1383,14 +1344,53 @@
       </p:sp>
       <p:sp>
         <p:nvSpPr>
+          <p:cNvPr id="10" name="Text 8"/>
+          <p:cNvSpPr/>
+          <p:nvPr/>
+        </p:nvSpPr>
+        <p:spPr>
+          <a:xfrm>
+            <a:off x="822960" y="8906256"/>
+            <a:ext cx="1554480" cy="292608"/>
+          </a:xfrm>
+          <a:prstGeom prst="rect">
+            <a:avLst/>
+          </a:prstGeom>
+          <a:noFill/>
+          <a:ln/>
+        </p:spPr>
+        <p:txBody>
+          <a:bodyPr wrap="square" lIns="0" tIns="0" rIns="0" bIns="0" rtlCol="0" anchor="ctr"/>
+          <a:lstStyle/>
+          <a:p>
+            <a:pPr indent="0" marL="0">
+              <a:buNone/>
+            </a:pPr>
+            <a:r>
+              <a:rPr lang="en-US" sz="1200" b="1" spc="150" kern="0" dirty="0">
+                <a:solidFill>
+                  <a:srgbClr val="009CFF"/>
+                </a:solidFill>
+                <a:latin typeface="Calibri" pitchFamily="34" charset="0"/>
+                <a:ea typeface="Calibri" pitchFamily="34" charset="-122"/>
+                <a:cs typeface="Calibri" pitchFamily="34" charset="-120"/>
+              </a:rPr>
+              <a:t>DÍA</a:t>
+            </a:r>
+            <a:endParaRPr lang="en-US" sz="1200" dirty="0"/>
+          </a:p>
+        </p:txBody>
+      </p:sp>
+      <p:sp>
+        <p:nvSpPr>
           <p:cNvPr id="11" name="Text 9"/>
           <p:cNvSpPr/>
           <p:nvPr/>
         </p:nvSpPr>
         <p:spPr>
           <a:xfrm>
-            <a:off x="868680" y="9235440"/>
-            <a:ext cx="1828800" cy="256032"/>
+            <a:off x="2377440" y="8869680"/>
+            <a:ext cx="3749040" cy="365760"/>
           </a:xfrm>
           <a:prstGeom prst="rect">
             <a:avLst/>
@@ -1406,30 +1406,57 @@
               <a:buNone/>
             </a:pPr>
             <a:r>
-              <a:rPr lang="en-US" sz="1100" b="1" spc="150" kern="0" dirty="0">
-                <a:solidFill>
-                  <a:srgbClr val="767D9E"/>
-                </a:solidFill>
-                <a:latin typeface="Calibri" pitchFamily="34" charset="0"/>
-                <a:ea typeface="Calibri" pitchFamily="34" charset="-122"/>
-                <a:cs typeface="Calibri" pitchFamily="34" charset="-120"/>
-              </a:rPr>
-              <a:t>ANTES</a:t>
-            </a:r>
-            <a:endParaRPr lang="en-US" sz="1100" dirty="0"/>
-          </a:p>
-        </p:txBody>
-      </p:sp>
-      <p:sp>
-        <p:nvSpPr>
-          <p:cNvPr id="12" name="Text 10"/>
-          <p:cNvSpPr/>
-          <p:nvPr/>
-        </p:nvSpPr>
-        <p:spPr>
-          <a:xfrm>
-            <a:off x="868680" y="9491472"/>
-            <a:ext cx="2011680" cy="502920"/>
+              <a:rPr lang="en-US" sz="1600" dirty="0">
+                <a:solidFill>
+                  <a:srgbClr val="FFFFFF"/>
+                </a:solidFill>
+                <a:latin typeface="Calibri" pitchFamily="34" charset="0"/>
+                <a:ea typeface="Calibri" pitchFamily="34" charset="-122"/>
+                <a:cs typeface="Calibri" pitchFamily="34" charset="-120"/>
+              </a:rPr>
+              <a:t>[Viernes 00 de mes]</a:t>
+            </a:r>
+            <a:endParaRPr lang="en-US" sz="1600" dirty="0"/>
+          </a:p>
+        </p:txBody>
+      </p:sp>
+      <p:sp>
+        <p:nvSpPr>
+          <p:cNvPr id="12" name="Shape 10"/>
+          <p:cNvSpPr/>
+          <p:nvPr/>
+        </p:nvSpPr>
+        <p:spPr>
+          <a:xfrm>
+            <a:off x="548640" y="9482328"/>
+            <a:ext cx="5760720" cy="640080"/>
+          </a:xfrm>
+          <a:prstGeom prst="roundRect">
+            <a:avLst>
+              <a:gd name="adj" fmla="val 14286"/>
+            </a:avLst>
+          </a:prstGeom>
+          <a:solidFill>
+            <a:srgbClr val="2C3050"/>
+          </a:solidFill>
+          <a:ln w="12700">
+            <a:solidFill>
+              <a:srgbClr val="2C3050"/>
+            </a:solidFill>
+            <a:prstDash val="solid"/>
+          </a:ln>
+        </p:spPr>
+      </p:sp>
+      <p:sp>
+        <p:nvSpPr>
+          <p:cNvPr id="13" name="Text 11"/>
+          <p:cNvSpPr/>
+          <p:nvPr/>
+        </p:nvSpPr>
+        <p:spPr>
+          <a:xfrm>
+            <a:off x="822960" y="9656064"/>
+            <a:ext cx="1554480" cy="292608"/>
           </a:xfrm>
           <a:prstGeom prst="rect">
             <a:avLst/>
@@ -1445,30 +1472,30 @@
               <a:buNone/>
             </a:pPr>
             <a:r>
-              <a:rPr lang="en-US" sz="2600" b="1" strike="sngStrike" dirty="0">
-                <a:solidFill>
-                  <a:srgbClr val="767D9E"/>
-                </a:solidFill>
-                <a:latin typeface="Calibri" pitchFamily="34" charset="0"/>
-                <a:ea typeface="Calibri" pitchFamily="34" charset="-122"/>
-                <a:cs typeface="Calibri" pitchFamily="34" charset="-120"/>
-              </a:rPr>
-              <a:t>$0,000</a:t>
-            </a:r>
-            <a:endParaRPr lang="en-US" sz="2600" dirty="0"/>
-          </a:p>
-        </p:txBody>
-      </p:sp>
-      <p:sp>
-        <p:nvSpPr>
-          <p:cNvPr id="13" name="Text 11"/>
-          <p:cNvSpPr/>
-          <p:nvPr/>
-        </p:nvSpPr>
-        <p:spPr>
-          <a:xfrm>
-            <a:off x="3200400" y="9235440"/>
-            <a:ext cx="1828800" cy="256032"/>
+              <a:rPr lang="en-US" sz="1200" b="1" spc="150" kern="0" dirty="0">
+                <a:solidFill>
+                  <a:srgbClr val="009CFF"/>
+                </a:solidFill>
+                <a:latin typeface="Calibri" pitchFamily="34" charset="0"/>
+                <a:ea typeface="Calibri" pitchFamily="34" charset="-122"/>
+                <a:cs typeface="Calibri" pitchFamily="34" charset="-120"/>
+              </a:rPr>
+              <a:t>HORARIO</a:t>
+            </a:r>
+            <a:endParaRPr lang="en-US" sz="1200" dirty="0"/>
+          </a:p>
+        </p:txBody>
+      </p:sp>
+      <p:sp>
+        <p:nvSpPr>
+          <p:cNvPr id="14" name="Text 12"/>
+          <p:cNvSpPr/>
+          <p:nvPr/>
+        </p:nvSpPr>
+        <p:spPr>
+          <a:xfrm>
+            <a:off x="2377440" y="9619488"/>
+            <a:ext cx="3749040" cy="365760"/>
           </a:xfrm>
           <a:prstGeom prst="rect">
             <a:avLst/>
@@ -1484,7 +1511,73 @@
               <a:buNone/>
             </a:pPr>
             <a:r>
-              <a:rPr lang="en-US" sz="1100" b="1" spc="150" kern="0" dirty="0">
+              <a:rPr lang="en-US" sz="1600" dirty="0">
+                <a:solidFill>
+                  <a:srgbClr val="FFFFFF"/>
+                </a:solidFill>
+                <a:latin typeface="Calibri" pitchFamily="34" charset="0"/>
+                <a:ea typeface="Calibri" pitchFamily="34" charset="-122"/>
+                <a:cs typeface="Calibri" pitchFamily="34" charset="-120"/>
+              </a:rPr>
+              <a:t>[9:00 PM – 3:00 AM]</a:t>
+            </a:r>
+            <a:endParaRPr lang="en-US" sz="1600" dirty="0"/>
+          </a:p>
+        </p:txBody>
+      </p:sp>
+      <p:sp>
+        <p:nvSpPr>
+          <p:cNvPr id="15" name="Shape 13"/>
+          <p:cNvSpPr/>
+          <p:nvPr/>
+        </p:nvSpPr>
+        <p:spPr>
+          <a:xfrm>
+            <a:off x="548640" y="10232136"/>
+            <a:ext cx="5760720" cy="640080"/>
+          </a:xfrm>
+          <a:prstGeom prst="roundRect">
+            <a:avLst>
+              <a:gd name="adj" fmla="val 14286"/>
+            </a:avLst>
+          </a:prstGeom>
+          <a:solidFill>
+            <a:srgbClr val="2C3050"/>
+          </a:solidFill>
+          <a:ln w="12700">
+            <a:solidFill>
+              <a:srgbClr val="2C3050"/>
+            </a:solidFill>
+            <a:prstDash val="solid"/>
+          </a:ln>
+        </p:spPr>
+      </p:sp>
+      <p:sp>
+        <p:nvSpPr>
+          <p:cNvPr id="16" name="Text 14"/>
+          <p:cNvSpPr/>
+          <p:nvPr/>
+        </p:nvSpPr>
+        <p:spPr>
+          <a:xfrm>
+            <a:off x="822960" y="10405872"/>
+            <a:ext cx="1554480" cy="292608"/>
+          </a:xfrm>
+          <a:prstGeom prst="rect">
+            <a:avLst/>
+          </a:prstGeom>
+          <a:noFill/>
+          <a:ln/>
+        </p:spPr>
+        <p:txBody>
+          <a:bodyPr wrap="square" lIns="0" tIns="0" rIns="0" bIns="0" rtlCol="0" anchor="ctr"/>
+          <a:lstStyle/>
+          <a:p>
+            <a:pPr indent="0" marL="0">
+              <a:buNone/>
+            </a:pPr>
+            <a:r>
+              <a:rPr lang="en-US" sz="1200" b="1" spc="150" kern="0" dirty="0">
                 <a:solidFill>
                   <a:srgbClr val="009CFF"/>
                 </a:solidFill>
@@ -1492,22 +1585,22 @@
                 <a:ea typeface="Calibri" pitchFamily="34" charset="-122"/>
                 <a:cs typeface="Calibri" pitchFamily="34" charset="-120"/>
               </a:rPr>
-              <a:t>HOY</a:t>
-            </a:r>
-            <a:endParaRPr lang="en-US" sz="1100" dirty="0"/>
-          </a:p>
-        </p:txBody>
-      </p:sp>
-      <p:sp>
-        <p:nvSpPr>
-          <p:cNvPr id="14" name="Text 12"/>
-          <p:cNvSpPr/>
-          <p:nvPr/>
-        </p:nvSpPr>
-        <p:spPr>
-          <a:xfrm>
-            <a:off x="3200400" y="9418320"/>
-            <a:ext cx="2926080" cy="731520"/>
+              <a:t>EVENTO</a:t>
+            </a:r>
+            <a:endParaRPr lang="en-US" sz="1200" dirty="0"/>
+          </a:p>
+        </p:txBody>
+      </p:sp>
+      <p:sp>
+        <p:nvSpPr>
+          <p:cNvPr id="17" name="Text 15"/>
+          <p:cNvSpPr/>
+          <p:nvPr/>
+        </p:nvSpPr>
+        <p:spPr>
+          <a:xfrm>
+            <a:off x="2377440" y="10369296"/>
+            <a:ext cx="3749040" cy="365760"/>
           </a:xfrm>
           <a:prstGeom prst="rect">
             <a:avLst/>
@@ -1523,7 +1616,7 @@
               <a:buNone/>
             </a:pPr>
             <a:r>
-              <a:rPr lang="en-US" sz="4000" b="1" dirty="0">
+              <a:rPr lang="en-US" sz="1600" dirty="0">
                 <a:solidFill>
                   <a:srgbClr val="FFFFFF"/>
                 </a:solidFill>
@@ -1531,60 +1624,21 @@
                 <a:ea typeface="Calibri" pitchFamily="34" charset="-122"/>
                 <a:cs typeface="Calibri" pitchFamily="34" charset="-120"/>
               </a:rPr>
-              <a:t>$0,000</a:t>
-            </a:r>
-            <a:endParaRPr lang="en-US" sz="4000" dirty="0"/>
-          </a:p>
-        </p:txBody>
-      </p:sp>
-      <p:sp>
-        <p:nvSpPr>
-          <p:cNvPr id="15" name="Text 13"/>
-          <p:cNvSpPr/>
-          <p:nvPr/>
-        </p:nvSpPr>
-        <p:spPr>
-          <a:xfrm>
-            <a:off x="868680" y="10195560"/>
-            <a:ext cx="5120640" cy="274320"/>
-          </a:xfrm>
-          <a:prstGeom prst="rect">
-            <a:avLst/>
-          </a:prstGeom>
-          <a:noFill/>
-          <a:ln/>
-        </p:spPr>
-        <p:txBody>
-          <a:bodyPr wrap="square" lIns="0" tIns="0" rIns="0" bIns="0" rtlCol="0" anchor="ctr"/>
-          <a:lstStyle/>
-          <a:p>
-            <a:pPr indent="0" marL="0">
-              <a:buNone/>
-            </a:pPr>
-            <a:r>
-              <a:rPr lang="en-US" sz="1300" dirty="0">
-                <a:solidFill>
-                  <a:srgbClr val="D9DDEE"/>
-                </a:solidFill>
-                <a:latin typeface="Calibri" pitchFamily="34" charset="0"/>
-                <a:ea typeface="Calibri" pitchFamily="34" charset="-122"/>
-                <a:cs typeface="Calibri" pitchFamily="34" charset="-120"/>
-              </a:rPr>
-              <a:t>Válido solo [fecha / vigencia]</a:t>
-            </a:r>
-            <a:endParaRPr lang="en-US" sz="1300" dirty="0"/>
-          </a:p>
-        </p:txBody>
-      </p:sp>
-      <p:sp>
-        <p:nvSpPr>
-          <p:cNvPr id="16" name="Shape 14"/>
-          <p:cNvSpPr/>
-          <p:nvPr/>
-        </p:nvSpPr>
-        <p:spPr>
-          <a:xfrm>
-            <a:off x="548640" y="10881360"/>
+              <a:t>[DJ invitado / show de la noche]</a:t>
+            </a:r>
+            <a:endParaRPr lang="en-US" sz="1600" dirty="0"/>
+          </a:p>
+        </p:txBody>
+      </p:sp>
+      <p:sp>
+        <p:nvSpPr>
+          <p:cNvPr id="18" name="Shape 16"/>
+          <p:cNvSpPr/>
+          <p:nvPr/>
+        </p:nvSpPr>
+        <p:spPr>
+          <a:xfrm>
+            <a:off x="548640" y="11109960"/>
             <a:ext cx="5760720" cy="685800"/>
           </a:xfrm>
           <a:prstGeom prst="roundRect">
@@ -1605,13 +1659,13 @@
       </p:sp>
       <p:sp>
         <p:nvSpPr>
-          <p:cNvPr id="17" name="Text 15"/>
-          <p:cNvSpPr/>
-          <p:nvPr/>
-        </p:nvSpPr>
-        <p:spPr>
-          <a:xfrm>
-            <a:off x="548640" y="10881360"/>
+          <p:cNvPr id="19" name="Text 17"/>
+          <p:cNvSpPr/>
+          <p:nvPr/>
+        </p:nvSpPr>
+        <p:spPr>
+          <a:xfrm>
+            <a:off x="548640" y="11109960"/>
             <a:ext cx="5760720" cy="685800"/>
           </a:xfrm>
           <a:prstGeom prst="rect">
@@ -1636,7 +1690,7 @@
                 <a:ea typeface="Calibri" pitchFamily="34" charset="-122"/>
                 <a:cs typeface="Calibri" pitchFamily="34" charset="-120"/>
               </a:rPr>
-              <a:t>Responde esta historia para apartar</a:t>
+              <a:t>Reserva por WhatsApp</a:t>
             </a:r>
             <a:endParaRPr lang="en-US" sz="1700" dirty="0"/>
           </a:p>
@@ -1761,7 +1815,7 @@
         <p:spPr>
           <a:xfrm>
             <a:off x="0" y="1051560"/>
-            <a:ext cx="6858000" cy="4572000"/>
+            <a:ext cx="6858000" cy="5669280"/>
           </a:xfrm>
           <a:prstGeom prst="rect">
             <a:avLst/>
@@ -1785,8 +1839,8 @@
         </p:nvSpPr>
         <p:spPr>
           <a:xfrm>
-            <a:off x="731520" y="3017520"/>
-            <a:ext cx="5394960" cy="640080"/>
+            <a:off x="731520" y="3520440"/>
+            <a:ext cx="5394960" cy="731520"/>
           </a:xfrm>
           <a:prstGeom prst="rect">
             <a:avLst/>
@@ -1810,10 +1864,27 @@
                 <a:ea typeface="Calibri" pitchFamily="34" charset="-122"/>
                 <a:cs typeface="Calibri" pitchFamily="34" charset="-120"/>
               </a:rPr>
-              <a:t>INSERTA AQUÍ tu foto de la mesa VIP montada</a:t>
+              <a:t>INSERTA AQUÍ la foto de botella o coctel</a:t>
             </a:r>
             <a:endParaRPr lang="en-US" sz="1200" dirty="0"/>
           </a:p>
+          <a:p>
+            <a:pPr algn="ctr" indent="0" marL="0">
+              <a:buNone/>
+            </a:pPr>
+            <a:r>
+              <a:rPr lang="en-US" sz="1200" i="1" dirty="0">
+                <a:solidFill>
+                  <a:srgbClr val="767D9E"/>
+                </a:solidFill>
+                <a:latin typeface="Calibri" pitchFamily="34" charset="0"/>
+                <a:ea typeface="Calibri" pitchFamily="34" charset="-122"/>
+                <a:cs typeface="Calibri" pitchFamily="34" charset="-120"/>
+              </a:rPr>
+              <a:t>(sale del VIDEO 3 / POST 6)</a:t>
+            </a:r>
+            <a:endParaRPr lang="en-US" sz="1200" dirty="0"/>
+          </a:p>
         </p:txBody>
       </p:sp>
       <p:sp>
@@ -1824,7 +1895,7 @@
         </p:nvSpPr>
         <p:spPr>
           <a:xfrm>
-            <a:off x="548640" y="6080760"/>
+            <a:off x="548640" y="7205472"/>
             <a:ext cx="201168" cy="201168"/>
           </a:xfrm>
           <a:prstGeom prst="diamond">
@@ -1849,8 +1920,8 @@
         </p:nvSpPr>
         <p:spPr>
           <a:xfrm>
-            <a:off x="914400" y="6053328"/>
-            <a:ext cx="4572000" cy="274320"/>
+            <a:off x="914400" y="7178040"/>
+            <a:ext cx="5029200" cy="274320"/>
           </a:xfrm>
           <a:prstGeom prst="rect">
             <a:avLst/>
@@ -1874,7 +1945,7 @@
                 <a:ea typeface="Calibri" pitchFamily="34" charset="-122"/>
                 <a:cs typeface="Calibri" pitchFamily="34" charset="-120"/>
               </a:rPr>
-              <a:t>C O M B O   D E L   F I N</a:t>
+              <a:t>P R O M O   D E L   D Í A</a:t>
             </a:r>
             <a:endParaRPr lang="en-US" sz="1200" dirty="0"/>
           </a:p>
@@ -1888,8 +1959,8 @@
         </p:nvSpPr>
         <p:spPr>
           <a:xfrm>
-            <a:off x="548640" y="6446520"/>
-            <a:ext cx="5760720" cy="777240"/>
+            <a:off x="548640" y="7589520"/>
+            <a:ext cx="5760720" cy="868680"/>
           </a:xfrm>
           <a:prstGeom prst="rect">
             <a:avLst/>
@@ -1913,7 +1984,7 @@
                 <a:ea typeface="Calibri" pitchFamily="34" charset="-122"/>
                 <a:cs typeface="Calibri" pitchFamily="34" charset="-120"/>
               </a:rPr>
-              <a:t>TODO INCLUIDO</a:t>
+              <a:t>[NOMBRE DE LA PROMO]</a:t>
             </a:r>
             <a:endParaRPr lang="en-US" sz="3800" dirty="0"/>
           </a:p>
@@ -1921,49 +1992,63 @@
       </p:sp>
       <p:sp>
         <p:nvSpPr>
-          <p:cNvPr id="9" name="Shape 7"/>
-          <p:cNvSpPr/>
-          <p:nvPr/>
-        </p:nvSpPr>
-        <p:spPr>
-          <a:xfrm>
-            <a:off x="548640" y="7360920"/>
-            <a:ext cx="5760720" cy="868680"/>
+          <p:cNvPr id="9" name="Text 7"/>
+          <p:cNvSpPr/>
+          <p:nvPr/>
+        </p:nvSpPr>
+        <p:spPr>
+          <a:xfrm>
+            <a:off x="548640" y="8412480"/>
+            <a:ext cx="5760720" cy="384048"/>
+          </a:xfrm>
+          <a:prstGeom prst="rect">
+            <a:avLst/>
+          </a:prstGeom>
+          <a:noFill/>
+          <a:ln/>
+        </p:spPr>
+        <p:txBody>
+          <a:bodyPr wrap="square" lIns="0" tIns="0" rIns="0" bIns="0" rtlCol="0" anchor="ctr"/>
+          <a:lstStyle/>
+          <a:p>
+            <a:pPr indent="0" marL="0">
+              <a:buNone/>
+            </a:pPr>
+            <a:r>
+              <a:rPr lang="en-US" sz="1700" dirty="0">
+                <a:solidFill>
+                  <a:srgbClr val="D9DDEE"/>
+                </a:solidFill>
+                <a:latin typeface="Calibri" pitchFamily="34" charset="0"/>
+                <a:ea typeface="Calibri" pitchFamily="34" charset="-122"/>
+                <a:cs typeface="Calibri" pitchFamily="34" charset="-120"/>
+              </a:rPr>
+              <a:t>[Qué incluye en una línea]</a:t>
+            </a:r>
+            <a:endParaRPr lang="en-US" sz="1700" dirty="0"/>
+          </a:p>
+        </p:txBody>
+      </p:sp>
+      <p:sp>
+        <p:nvSpPr>
+          <p:cNvPr id="10" name="Shape 8"/>
+          <p:cNvSpPr/>
+          <p:nvPr/>
+        </p:nvSpPr>
+        <p:spPr>
+          <a:xfrm>
+            <a:off x="548640" y="9098280"/>
+            <a:ext cx="5760720" cy="1600200"/>
           </a:xfrm>
           <a:prstGeom prst="roundRect">
             <a:avLst>
-              <a:gd name="adj" fmla="val 10526"/>
+              <a:gd name="adj" fmla="val 6857"/>
             </a:avLst>
           </a:prstGeom>
           <a:solidFill>
             <a:srgbClr val="2C3050"/>
           </a:solidFill>
-          <a:ln w="12700">
-            <a:solidFill>
-              <a:srgbClr val="2C3050"/>
-            </a:solidFill>
-            <a:prstDash val="solid"/>
-          </a:ln>
-        </p:spPr>
-      </p:sp>
-      <p:sp>
-        <p:nvSpPr>
-          <p:cNvPr id="10" name="Shape 8"/>
-          <p:cNvSpPr/>
-          <p:nvPr/>
-        </p:nvSpPr>
-        <p:spPr>
-          <a:xfrm>
-            <a:off x="777240" y="7543800"/>
-            <a:ext cx="502920" cy="502920"/>
-          </a:xfrm>
-          <a:prstGeom prst="ellipse">
-            <a:avLst/>
-          </a:prstGeom>
-          <a:solidFill>
-            <a:srgbClr val="009CFF"/>
-          </a:solidFill>
-          <a:ln w="12700">
+          <a:ln w="19050">
             <a:solidFill>
               <a:srgbClr val="009CFF"/>
             </a:solidFill>
@@ -1979,24 +2064,141 @@
         </p:nvSpPr>
         <p:spPr>
           <a:xfrm>
-            <a:off x="777240" y="7543800"/>
-            <a:ext cx="502920" cy="502920"/>
-          </a:xfrm>
-          <a:prstGeom prst="rect">
-            <a:avLst/>
-          </a:prstGeom>
-          <a:noFill/>
-          <a:ln/>
-        </p:spPr>
-        <p:txBody>
-          <a:bodyPr wrap="square" lIns="0" tIns="0" rIns="0" bIns="0" rtlCol="0" anchor="ctr"/>
-          <a:lstStyle/>
-          <a:p>
-            <a:pPr algn="ctr" indent="0" marL="0">
-              <a:buNone/>
-            </a:pPr>
-            <a:r>
-              <a:rPr lang="en-US" sz="2000" b="1" dirty="0">
+            <a:off x="868680" y="9281160"/>
+            <a:ext cx="1828800" cy="256032"/>
+          </a:xfrm>
+          <a:prstGeom prst="rect">
+            <a:avLst/>
+          </a:prstGeom>
+          <a:noFill/>
+          <a:ln/>
+        </p:spPr>
+        <p:txBody>
+          <a:bodyPr wrap="square" lIns="0" tIns="0" rIns="0" bIns="0" rtlCol="0" anchor="ctr"/>
+          <a:lstStyle/>
+          <a:p>
+            <a:pPr indent="0" marL="0">
+              <a:buNone/>
+            </a:pPr>
+            <a:r>
+              <a:rPr lang="en-US" sz="1100" b="1" spc="150" kern="0" dirty="0">
+                <a:solidFill>
+                  <a:srgbClr val="767D9E"/>
+                </a:solidFill>
+                <a:latin typeface="Calibri" pitchFamily="34" charset="0"/>
+                <a:ea typeface="Calibri" pitchFamily="34" charset="-122"/>
+                <a:cs typeface="Calibri" pitchFamily="34" charset="-120"/>
+              </a:rPr>
+              <a:t>ANTES</a:t>
+            </a:r>
+            <a:endParaRPr lang="en-US" sz="1100" dirty="0"/>
+          </a:p>
+        </p:txBody>
+      </p:sp>
+      <p:sp>
+        <p:nvSpPr>
+          <p:cNvPr id="12" name="Text 10"/>
+          <p:cNvSpPr/>
+          <p:nvPr/>
+        </p:nvSpPr>
+        <p:spPr>
+          <a:xfrm>
+            <a:off x="868680" y="9537192"/>
+            <a:ext cx="2011680" cy="502920"/>
+          </a:xfrm>
+          <a:prstGeom prst="rect">
+            <a:avLst/>
+          </a:prstGeom>
+          <a:noFill/>
+          <a:ln/>
+        </p:spPr>
+        <p:txBody>
+          <a:bodyPr wrap="square" lIns="0" tIns="0" rIns="0" bIns="0" rtlCol="0" anchor="ctr"/>
+          <a:lstStyle/>
+          <a:p>
+            <a:pPr indent="0" marL="0">
+              <a:buNone/>
+            </a:pPr>
+            <a:r>
+              <a:rPr lang="en-US" sz="2600" b="1" strike="sngStrike" dirty="0">
+                <a:solidFill>
+                  <a:srgbClr val="767D9E"/>
+                </a:solidFill>
+                <a:latin typeface="Calibri" pitchFamily="34" charset="0"/>
+                <a:ea typeface="Calibri" pitchFamily="34" charset="-122"/>
+                <a:cs typeface="Calibri" pitchFamily="34" charset="-120"/>
+              </a:rPr>
+              <a:t>$0,000</a:t>
+            </a:r>
+            <a:endParaRPr lang="en-US" sz="2600" dirty="0"/>
+          </a:p>
+        </p:txBody>
+      </p:sp>
+      <p:sp>
+        <p:nvSpPr>
+          <p:cNvPr id="13" name="Text 11"/>
+          <p:cNvSpPr/>
+          <p:nvPr/>
+        </p:nvSpPr>
+        <p:spPr>
+          <a:xfrm>
+            <a:off x="3200400" y="9281160"/>
+            <a:ext cx="1828800" cy="256032"/>
+          </a:xfrm>
+          <a:prstGeom prst="rect">
+            <a:avLst/>
+          </a:prstGeom>
+          <a:noFill/>
+          <a:ln/>
+        </p:spPr>
+        <p:txBody>
+          <a:bodyPr wrap="square" lIns="0" tIns="0" rIns="0" bIns="0" rtlCol="0" anchor="ctr"/>
+          <a:lstStyle/>
+          <a:p>
+            <a:pPr indent="0" marL="0">
+              <a:buNone/>
+            </a:pPr>
+            <a:r>
+              <a:rPr lang="en-US" sz="1100" b="1" spc="150" kern="0" dirty="0">
+                <a:solidFill>
+                  <a:srgbClr val="009CFF"/>
+                </a:solidFill>
+                <a:latin typeface="Calibri" pitchFamily="34" charset="0"/>
+                <a:ea typeface="Calibri" pitchFamily="34" charset="-122"/>
+                <a:cs typeface="Calibri" pitchFamily="34" charset="-120"/>
+              </a:rPr>
+              <a:t>HOY</a:t>
+            </a:r>
+            <a:endParaRPr lang="en-US" sz="1100" dirty="0"/>
+          </a:p>
+        </p:txBody>
+      </p:sp>
+      <p:sp>
+        <p:nvSpPr>
+          <p:cNvPr id="14" name="Text 12"/>
+          <p:cNvSpPr/>
+          <p:nvPr/>
+        </p:nvSpPr>
+        <p:spPr>
+          <a:xfrm>
+            <a:off x="3200400" y="9464040"/>
+            <a:ext cx="2926080" cy="731520"/>
+          </a:xfrm>
+          <a:prstGeom prst="rect">
+            <a:avLst/>
+          </a:prstGeom>
+          <a:noFill/>
+          <a:ln/>
+        </p:spPr>
+        <p:txBody>
+          <a:bodyPr wrap="square" lIns="0" tIns="0" rIns="0" bIns="0" rtlCol="0" anchor="ctr"/>
+          <a:lstStyle/>
+          <a:p>
+            <a:pPr indent="0" marL="0">
+              <a:buNone/>
+            </a:pPr>
+            <a:r>
+              <a:rPr lang="en-US" sz="4000" b="1" dirty="0">
                 <a:solidFill>
                   <a:srgbClr val="FFFFFF"/>
                 </a:solidFill>
@@ -2004,22 +2206,22 @@
                 <a:ea typeface="Calibri" pitchFamily="34" charset="-122"/>
                 <a:cs typeface="Calibri" pitchFamily="34" charset="-120"/>
               </a:rPr>
-              <a:t>1</a:t>
-            </a:r>
-            <a:endParaRPr lang="en-US" sz="2000" dirty="0"/>
-          </a:p>
-        </p:txBody>
-      </p:sp>
-      <p:sp>
-        <p:nvSpPr>
-          <p:cNvPr id="12" name="Text 10"/>
-          <p:cNvSpPr/>
-          <p:nvPr/>
-        </p:nvSpPr>
-        <p:spPr>
-          <a:xfrm>
-            <a:off x="1463040" y="7516368"/>
-            <a:ext cx="4480560" cy="292608"/>
+              <a:t>$0,000</a:t>
+            </a:r>
+            <a:endParaRPr lang="en-US" sz="4000" dirty="0"/>
+          </a:p>
+        </p:txBody>
+      </p:sp>
+      <p:sp>
+        <p:nvSpPr>
+          <p:cNvPr id="15" name="Text 13"/>
+          <p:cNvSpPr/>
+          <p:nvPr/>
+        </p:nvSpPr>
+        <p:spPr>
+          <a:xfrm>
+            <a:off x="868680" y="10241280"/>
+            <a:ext cx="5120640" cy="274320"/>
           </a:xfrm>
           <a:prstGeom prst="rect">
             <a:avLst/>
@@ -2035,45 +2237,6 @@
               <a:buNone/>
             </a:pPr>
             <a:r>
-              <a:rPr lang="en-US" sz="1700" b="1" dirty="0">
-                <a:solidFill>
-                  <a:srgbClr val="FFFFFF"/>
-                </a:solidFill>
-                <a:latin typeface="Calibri" pitchFamily="34" charset="0"/>
-                <a:ea typeface="Calibri" pitchFamily="34" charset="-122"/>
-                <a:cs typeface="Calibri" pitchFamily="34" charset="-120"/>
-              </a:rPr>
-              <a:t>MESA</a:t>
-            </a:r>
-            <a:endParaRPr lang="en-US" sz="1700" dirty="0"/>
-          </a:p>
-        </p:txBody>
-      </p:sp>
-      <p:sp>
-        <p:nvSpPr>
-          <p:cNvPr id="13" name="Text 11"/>
-          <p:cNvSpPr/>
-          <p:nvPr/>
-        </p:nvSpPr>
-        <p:spPr>
-          <a:xfrm>
-            <a:off x="1463040" y="7818120"/>
-            <a:ext cx="4480560" cy="274320"/>
-          </a:xfrm>
-          <a:prstGeom prst="rect">
-            <a:avLst/>
-          </a:prstGeom>
-          <a:noFill/>
-          <a:ln/>
-        </p:spPr>
-        <p:txBody>
-          <a:bodyPr wrap="square" lIns="0" tIns="0" rIns="0" bIns="0" rtlCol="0" anchor="ctr"/>
-          <a:lstStyle/>
-          <a:p>
-            <a:pPr indent="0" marL="0">
-              <a:buNone/>
-            </a:pPr>
-            <a:r>
               <a:rPr lang="en-US" sz="1300" dirty="0">
                 <a:solidFill>
                   <a:srgbClr val="D9DDEE"/>
@@ -2082,7 +2245,7 @@
                 <a:ea typeface="Calibri" pitchFamily="34" charset="-122"/>
                 <a:cs typeface="Calibri" pitchFamily="34" charset="-120"/>
               </a:rPr>
-              <a:t>[Capacidad / zona]</a:t>
+              <a:t>Válido solo [vigencia]</a:t>
             </a:r>
             <a:endParaRPr lang="en-US" sz="1300" dirty="0"/>
           </a:p>
@@ -2090,434 +2253,18 @@
       </p:sp>
       <p:sp>
         <p:nvSpPr>
-          <p:cNvPr id="14" name="Shape 12"/>
-          <p:cNvSpPr/>
-          <p:nvPr/>
-        </p:nvSpPr>
-        <p:spPr>
-          <a:xfrm>
-            <a:off x="548640" y="8412480"/>
-            <a:ext cx="5760720" cy="868680"/>
+          <p:cNvPr id="16" name="Shape 14"/>
+          <p:cNvSpPr/>
+          <p:nvPr/>
+        </p:nvSpPr>
+        <p:spPr>
+          <a:xfrm>
+            <a:off x="548640" y="10927080"/>
+            <a:ext cx="5760720" cy="685800"/>
           </a:xfrm>
           <a:prstGeom prst="roundRect">
             <a:avLst>
-              <a:gd name="adj" fmla="val 10526"/>
-            </a:avLst>
-          </a:prstGeom>
-          <a:solidFill>
-            <a:srgbClr val="2C3050"/>
-          </a:solidFill>
-          <a:ln w="12700">
-            <a:solidFill>
-              <a:srgbClr val="2C3050"/>
-            </a:solidFill>
-            <a:prstDash val="solid"/>
-          </a:ln>
-        </p:spPr>
-      </p:sp>
-      <p:sp>
-        <p:nvSpPr>
-          <p:cNvPr id="15" name="Shape 13"/>
-          <p:cNvSpPr/>
-          <p:nvPr/>
-        </p:nvSpPr>
-        <p:spPr>
-          <a:xfrm>
-            <a:off x="777240" y="8595360"/>
-            <a:ext cx="502920" cy="502920"/>
-          </a:xfrm>
-          <a:prstGeom prst="ellipse">
-            <a:avLst/>
-          </a:prstGeom>
-          <a:solidFill>
-            <a:srgbClr val="009CFF"/>
-          </a:solidFill>
-          <a:ln w="12700">
-            <a:solidFill>
-              <a:srgbClr val="009CFF"/>
-            </a:solidFill>
-            <a:prstDash val="solid"/>
-          </a:ln>
-        </p:spPr>
-      </p:sp>
-      <p:sp>
-        <p:nvSpPr>
-          <p:cNvPr id="16" name="Text 14"/>
-          <p:cNvSpPr/>
-          <p:nvPr/>
-        </p:nvSpPr>
-        <p:spPr>
-          <a:xfrm>
-            <a:off x="777240" y="8595360"/>
-            <a:ext cx="502920" cy="502920"/>
-          </a:xfrm>
-          <a:prstGeom prst="rect">
-            <a:avLst/>
-          </a:prstGeom>
-          <a:noFill/>
-          <a:ln/>
-        </p:spPr>
-        <p:txBody>
-          <a:bodyPr wrap="square" lIns="0" tIns="0" rIns="0" bIns="0" rtlCol="0" anchor="ctr"/>
-          <a:lstStyle/>
-          <a:p>
-            <a:pPr algn="ctr" indent="0" marL="0">
-              <a:buNone/>
-            </a:pPr>
-            <a:r>
-              <a:rPr lang="en-US" sz="2000" b="1" dirty="0">
-                <a:solidFill>
-                  <a:srgbClr val="FFFFFF"/>
-                </a:solidFill>
-                <a:latin typeface="Calibri" pitchFamily="34" charset="0"/>
-                <a:ea typeface="Calibri" pitchFamily="34" charset="-122"/>
-                <a:cs typeface="Calibri" pitchFamily="34" charset="-120"/>
-              </a:rPr>
-              <a:t>2</a:t>
-            </a:r>
-            <a:endParaRPr lang="en-US" sz="2000" dirty="0"/>
-          </a:p>
-        </p:txBody>
-      </p:sp>
-      <p:sp>
-        <p:nvSpPr>
-          <p:cNvPr id="17" name="Text 15"/>
-          <p:cNvSpPr/>
-          <p:nvPr/>
-        </p:nvSpPr>
-        <p:spPr>
-          <a:xfrm>
-            <a:off x="1463040" y="8567928"/>
-            <a:ext cx="4480560" cy="292608"/>
-          </a:xfrm>
-          <a:prstGeom prst="rect">
-            <a:avLst/>
-          </a:prstGeom>
-          <a:noFill/>
-          <a:ln/>
-        </p:spPr>
-        <p:txBody>
-          <a:bodyPr wrap="square" lIns="0" tIns="0" rIns="0" bIns="0" rtlCol="0" anchor="ctr"/>
-          <a:lstStyle/>
-          <a:p>
-            <a:pPr indent="0" marL="0">
-              <a:buNone/>
-            </a:pPr>
-            <a:r>
-              <a:rPr lang="en-US" sz="1700" b="1" dirty="0">
-                <a:solidFill>
-                  <a:srgbClr val="FFFFFF"/>
-                </a:solidFill>
-                <a:latin typeface="Calibri" pitchFamily="34" charset="0"/>
-                <a:ea typeface="Calibri" pitchFamily="34" charset="-122"/>
-                <a:cs typeface="Calibri" pitchFamily="34" charset="-120"/>
-              </a:rPr>
-              <a:t>BOTELLA</a:t>
-            </a:r>
-            <a:endParaRPr lang="en-US" sz="1700" dirty="0"/>
-          </a:p>
-        </p:txBody>
-      </p:sp>
-      <p:sp>
-        <p:nvSpPr>
-          <p:cNvPr id="18" name="Text 16"/>
-          <p:cNvSpPr/>
-          <p:nvPr/>
-        </p:nvSpPr>
-        <p:spPr>
-          <a:xfrm>
-            <a:off x="1463040" y="8869680"/>
-            <a:ext cx="4480560" cy="274320"/>
-          </a:xfrm>
-          <a:prstGeom prst="rect">
-            <a:avLst/>
-          </a:prstGeom>
-          <a:noFill/>
-          <a:ln/>
-        </p:spPr>
-        <p:txBody>
-          <a:bodyPr wrap="square" lIns="0" tIns="0" rIns="0" bIns="0" rtlCol="0" anchor="ctr"/>
-          <a:lstStyle/>
-          <a:p>
-            <a:pPr indent="0" marL="0">
-              <a:buNone/>
-            </a:pPr>
-            <a:r>
-              <a:rPr lang="en-US" sz="1300" dirty="0">
-                <a:solidFill>
-                  <a:srgbClr val="D9DDEE"/>
-                </a:solidFill>
-                <a:latin typeface="Calibri" pitchFamily="34" charset="0"/>
-                <a:ea typeface="Calibri" pitchFamily="34" charset="-122"/>
-                <a:cs typeface="Calibri" pitchFamily="34" charset="-120"/>
-              </a:rPr>
-              <a:t>[Marca incluida]</a:t>
-            </a:r>
-            <a:endParaRPr lang="en-US" sz="1300" dirty="0"/>
-          </a:p>
-        </p:txBody>
-      </p:sp>
-      <p:sp>
-        <p:nvSpPr>
-          <p:cNvPr id="19" name="Shape 17"/>
-          <p:cNvSpPr/>
-          <p:nvPr/>
-        </p:nvSpPr>
-        <p:spPr>
-          <a:xfrm>
-            <a:off x="548640" y="9464040"/>
-            <a:ext cx="5760720" cy="868680"/>
-          </a:xfrm>
-          <a:prstGeom prst="roundRect">
-            <a:avLst>
-              <a:gd name="adj" fmla="val 10526"/>
-            </a:avLst>
-          </a:prstGeom>
-          <a:solidFill>
-            <a:srgbClr val="2C3050"/>
-          </a:solidFill>
-          <a:ln w="12700">
-            <a:solidFill>
-              <a:srgbClr val="2C3050"/>
-            </a:solidFill>
-            <a:prstDash val="solid"/>
-          </a:ln>
-        </p:spPr>
-      </p:sp>
-      <p:sp>
-        <p:nvSpPr>
-          <p:cNvPr id="20" name="Shape 18"/>
-          <p:cNvSpPr/>
-          <p:nvPr/>
-        </p:nvSpPr>
-        <p:spPr>
-          <a:xfrm>
-            <a:off x="777240" y="9646920"/>
-            <a:ext cx="502920" cy="502920"/>
-          </a:xfrm>
-          <a:prstGeom prst="ellipse">
-            <a:avLst/>
-          </a:prstGeom>
-          <a:solidFill>
-            <a:srgbClr val="009CFF"/>
-          </a:solidFill>
-          <a:ln w="12700">
-            <a:solidFill>
-              <a:srgbClr val="009CFF"/>
-            </a:solidFill>
-            <a:prstDash val="solid"/>
-          </a:ln>
-        </p:spPr>
-      </p:sp>
-      <p:sp>
-        <p:nvSpPr>
-          <p:cNvPr id="21" name="Text 19"/>
-          <p:cNvSpPr/>
-          <p:nvPr/>
-        </p:nvSpPr>
-        <p:spPr>
-          <a:xfrm>
-            <a:off x="777240" y="9646920"/>
-            <a:ext cx="502920" cy="502920"/>
-          </a:xfrm>
-          <a:prstGeom prst="rect">
-            <a:avLst/>
-          </a:prstGeom>
-          <a:noFill/>
-          <a:ln/>
-        </p:spPr>
-        <p:txBody>
-          <a:bodyPr wrap="square" lIns="0" tIns="0" rIns="0" bIns="0" rtlCol="0" anchor="ctr"/>
-          <a:lstStyle/>
-          <a:p>
-            <a:pPr algn="ctr" indent="0" marL="0">
-              <a:buNone/>
-            </a:pPr>
-            <a:r>
-              <a:rPr lang="en-US" sz="2000" b="1" dirty="0">
-                <a:solidFill>
-                  <a:srgbClr val="FFFFFF"/>
-                </a:solidFill>
-                <a:latin typeface="Calibri" pitchFamily="34" charset="0"/>
-                <a:ea typeface="Calibri" pitchFamily="34" charset="-122"/>
-                <a:cs typeface="Calibri" pitchFamily="34" charset="-120"/>
-              </a:rPr>
-              <a:t>3</a:t>
-            </a:r>
-            <a:endParaRPr lang="en-US" sz="2000" dirty="0"/>
-          </a:p>
-        </p:txBody>
-      </p:sp>
-      <p:sp>
-        <p:nvSpPr>
-          <p:cNvPr id="22" name="Text 20"/>
-          <p:cNvSpPr/>
-          <p:nvPr/>
-        </p:nvSpPr>
-        <p:spPr>
-          <a:xfrm>
-            <a:off x="1463040" y="9619488"/>
-            <a:ext cx="4480560" cy="292608"/>
-          </a:xfrm>
-          <a:prstGeom prst="rect">
-            <a:avLst/>
-          </a:prstGeom>
-          <a:noFill/>
-          <a:ln/>
-        </p:spPr>
-        <p:txBody>
-          <a:bodyPr wrap="square" lIns="0" tIns="0" rIns="0" bIns="0" rtlCol="0" anchor="ctr"/>
-          <a:lstStyle/>
-          <a:p>
-            <a:pPr indent="0" marL="0">
-              <a:buNone/>
-            </a:pPr>
-            <a:r>
-              <a:rPr lang="en-US" sz="1700" b="1" dirty="0">
-                <a:solidFill>
-                  <a:srgbClr val="FFFFFF"/>
-                </a:solidFill>
-                <a:latin typeface="Calibri" pitchFamily="34" charset="0"/>
-                <a:ea typeface="Calibri" pitchFamily="34" charset="-122"/>
-                <a:cs typeface="Calibri" pitchFamily="34" charset="-120"/>
-              </a:rPr>
-              <a:t>MEZCLADORES</a:t>
-            </a:r>
-            <a:endParaRPr lang="en-US" sz="1700" dirty="0"/>
-          </a:p>
-        </p:txBody>
-      </p:sp>
-      <p:sp>
-        <p:nvSpPr>
-          <p:cNvPr id="23" name="Text 21"/>
-          <p:cNvSpPr/>
-          <p:nvPr/>
-        </p:nvSpPr>
-        <p:spPr>
-          <a:xfrm>
-            <a:off x="1463040" y="9921240"/>
-            <a:ext cx="4480560" cy="274320"/>
-          </a:xfrm>
-          <a:prstGeom prst="rect">
-            <a:avLst/>
-          </a:prstGeom>
-          <a:noFill/>
-          <a:ln/>
-        </p:spPr>
-        <p:txBody>
-          <a:bodyPr wrap="square" lIns="0" tIns="0" rIns="0" bIns="0" rtlCol="0" anchor="ctr"/>
-          <a:lstStyle/>
-          <a:p>
-            <a:pPr indent="0" marL="0">
-              <a:buNone/>
-            </a:pPr>
-            <a:r>
-              <a:rPr lang="en-US" sz="1300" dirty="0">
-                <a:solidFill>
-                  <a:srgbClr val="D9DDEE"/>
-                </a:solidFill>
-                <a:latin typeface="Calibri" pitchFamily="34" charset="0"/>
-                <a:ea typeface="Calibri" pitchFamily="34" charset="-122"/>
-                <a:cs typeface="Calibri" pitchFamily="34" charset="-120"/>
-              </a:rPr>
-              <a:t>[Cantidad / tipo]</a:t>
-            </a:r>
-            <a:endParaRPr lang="en-US" sz="1300" dirty="0"/>
-          </a:p>
-        </p:txBody>
-      </p:sp>
-      <p:sp>
-        <p:nvSpPr>
-          <p:cNvPr id="24" name="Text 22"/>
-          <p:cNvSpPr/>
-          <p:nvPr/>
-        </p:nvSpPr>
-        <p:spPr>
-          <a:xfrm>
-            <a:off x="548640" y="10378440"/>
-            <a:ext cx="3017520" cy="731520"/>
-          </a:xfrm>
-          <a:prstGeom prst="rect">
-            <a:avLst/>
-          </a:prstGeom>
-          <a:noFill/>
-          <a:ln/>
-        </p:spPr>
-        <p:txBody>
-          <a:bodyPr wrap="square" lIns="0" tIns="0" rIns="0" bIns="0" rtlCol="0" anchor="ctr"/>
-          <a:lstStyle/>
-          <a:p>
-            <a:pPr indent="0" marL="0">
-              <a:buNone/>
-            </a:pPr>
-            <a:r>
-              <a:rPr lang="en-US" sz="4600" b="1" dirty="0">
-                <a:solidFill>
-                  <a:srgbClr val="FFFFFF"/>
-                </a:solidFill>
-                <a:latin typeface="Calibri" pitchFamily="34" charset="0"/>
-                <a:ea typeface="Calibri" pitchFamily="34" charset="-122"/>
-                <a:cs typeface="Calibri" pitchFamily="34" charset="-120"/>
-              </a:rPr>
-              <a:t>$0,000</a:t>
-            </a:r>
-            <a:endParaRPr lang="en-US" sz="4600" dirty="0"/>
-          </a:p>
-        </p:txBody>
-      </p:sp>
-      <p:sp>
-        <p:nvSpPr>
-          <p:cNvPr id="25" name="Text 23"/>
-          <p:cNvSpPr/>
-          <p:nvPr/>
-        </p:nvSpPr>
-        <p:spPr>
-          <a:xfrm>
-            <a:off x="3520440" y="10652760"/>
-            <a:ext cx="2743200" cy="320040"/>
-          </a:xfrm>
-          <a:prstGeom prst="rect">
-            <a:avLst/>
-          </a:prstGeom>
-          <a:noFill/>
-          <a:ln/>
-        </p:spPr>
-        <p:txBody>
-          <a:bodyPr wrap="square" lIns="0" tIns="0" rIns="0" bIns="0" rtlCol="0" anchor="ctr"/>
-          <a:lstStyle/>
-          <a:p>
-            <a:pPr indent="0" marL="0">
-              <a:buNone/>
-            </a:pPr>
-            <a:r>
-              <a:rPr lang="en-US" sz="1400" dirty="0">
-                <a:solidFill>
-                  <a:srgbClr val="D9DDEE"/>
-                </a:solidFill>
-                <a:latin typeface="Calibri" pitchFamily="34" charset="0"/>
-                <a:ea typeface="Calibri" pitchFamily="34" charset="-122"/>
-                <a:cs typeface="Calibri" pitchFamily="34" charset="-120"/>
-              </a:rPr>
-              <a:t>por mesa completa</a:t>
-            </a:r>
-            <a:endParaRPr lang="en-US" sz="1400" dirty="0"/>
-          </a:p>
-        </p:txBody>
-      </p:sp>
-      <p:sp>
-        <p:nvSpPr>
-          <p:cNvPr id="26" name="Shape 24"/>
-          <p:cNvSpPr/>
-          <p:nvPr/>
-        </p:nvSpPr>
-        <p:spPr>
-          <a:xfrm>
-            <a:off x="548640" y="11109960"/>
-            <a:ext cx="5760720" cy="594360"/>
-          </a:xfrm>
-          <a:prstGeom prst="roundRect">
-            <a:avLst>
-              <a:gd name="adj" fmla="val 49231"/>
+              <a:gd name="adj" fmla="val 49333"/>
             </a:avLst>
           </a:prstGeom>
           <a:solidFill>
@@ -2533,14 +2280,14 @@
       </p:sp>
       <p:sp>
         <p:nvSpPr>
-          <p:cNvPr id="27" name="Text 25"/>
-          <p:cNvSpPr/>
-          <p:nvPr/>
-        </p:nvSpPr>
-        <p:spPr>
-          <a:xfrm>
-            <a:off x="548640" y="11109960"/>
-            <a:ext cx="5760720" cy="594360"/>
+          <p:cNvPr id="17" name="Text 15"/>
+          <p:cNvSpPr/>
+          <p:nvPr/>
+        </p:nvSpPr>
+        <p:spPr>
+          <a:xfrm>
+            <a:off x="548640" y="10927080"/>
+            <a:ext cx="5760720" cy="685800"/>
           </a:xfrm>
           <a:prstGeom prst="rect">
             <a:avLst/>
@@ -2556,7 +2303,7 @@
               <a:buNone/>
             </a:pPr>
             <a:r>
-              <a:rPr lang="en-US" sz="1600" b="1" dirty="0">
+              <a:rPr lang="en-US" sz="1700" b="1" dirty="0">
                 <a:solidFill>
                   <a:srgbClr val="FFFFFF"/>
                 </a:solidFill>
@@ -2564,9 +2311,9 @@
                 <a:ea typeface="Calibri" pitchFamily="34" charset="-122"/>
                 <a:cs typeface="Calibri" pitchFamily="34" charset="-120"/>
               </a:rPr>
-              <a:t>Aparta por WhatsApp</a:t>
-            </a:r>
-            <a:endParaRPr lang="en-US" sz="1600" dirty="0"/>
+              <a:t>Pídela al reservar</a:t>
+            </a:r>
+            <a:endParaRPr lang="en-US" sz="1700" dirty="0"/>
           </a:p>
         </p:txBody>
       </p:sp>
@@ -2689,7 +2436,7 @@
         <p:spPr>
           <a:xfrm>
             <a:off x="0" y="1051560"/>
-            <a:ext cx="6858000" cy="6492240"/>
+            <a:ext cx="6858000" cy="6400800"/>
           </a:xfrm>
           <a:prstGeom prst="rect">
             <a:avLst/>
@@ -2713,8 +2460,8 @@
         </p:nvSpPr>
         <p:spPr>
           <a:xfrm>
-            <a:off x="731520" y="3977640"/>
-            <a:ext cx="5394960" cy="640080"/>
+            <a:off x="731520" y="3886200"/>
+            <a:ext cx="5394960" cy="731520"/>
           </a:xfrm>
           <a:prstGeom prst="rect">
             <a:avLst/>
@@ -2738,7 +2485,7 @@
                 <a:ea typeface="Calibri" pitchFamily="34" charset="-122"/>
                 <a:cs typeface="Calibri" pitchFamily="34" charset="-120"/>
               </a:rPr>
-              <a:t>INSERTA AQUÍ tu foto del privado</a:t>
+              <a:t>INSERTA AQUÍ la foto del interior del privado</a:t>
             </a:r>
             <a:endParaRPr lang="en-US" sz="1200" dirty="0"/>
           </a:p>
@@ -2755,7 +2502,7 @@
                 <a:ea typeface="Calibri" pitchFamily="34" charset="-122"/>
                 <a:cs typeface="Calibri" pitchFamily="34" charset="-120"/>
               </a:rPr>
-              <a:t>(puerta semiabierta funciona mejor)</a:t>
+              <a:t>(sale del POST 7 — carrusel)</a:t>
             </a:r>
             <a:endParaRPr lang="en-US" sz="1200" dirty="0"/>
           </a:p>
@@ -2769,7 +2516,7 @@
         </p:nvSpPr>
         <p:spPr>
           <a:xfrm>
-            <a:off x="548640" y="8001000"/>
+            <a:off x="548640" y="7936992"/>
             <a:ext cx="201168" cy="201168"/>
           </a:xfrm>
           <a:prstGeom prst="diamond">
@@ -2794,8 +2541,8 @@
         </p:nvSpPr>
         <p:spPr>
           <a:xfrm>
-            <a:off x="914400" y="7973568"/>
-            <a:ext cx="4572000" cy="274320"/>
+            <a:off x="914400" y="7909560"/>
+            <a:ext cx="5029200" cy="274320"/>
           </a:xfrm>
           <a:prstGeom prst="rect">
             <a:avLst/>
@@ -2827,18 +2574,57 @@
       </p:sp>
       <p:sp>
         <p:nvSpPr>
-          <p:cNvPr id="8" name="Shape 6"/>
-          <p:cNvSpPr/>
-          <p:nvPr/>
-        </p:nvSpPr>
-        <p:spPr>
-          <a:xfrm>
-            <a:off x="548640" y="8412480"/>
-            <a:ext cx="5760720" cy="2103120"/>
+          <p:cNvPr id="8" name="Text 6"/>
+          <p:cNvSpPr/>
+          <p:nvPr/>
+        </p:nvSpPr>
+        <p:spPr>
+          <a:xfrm>
+            <a:off x="548640" y="8275320"/>
+            <a:ext cx="5760720" cy="685800"/>
+          </a:xfrm>
+          <a:prstGeom prst="rect">
+            <a:avLst/>
+          </a:prstGeom>
+          <a:noFill/>
+          <a:ln/>
+        </p:spPr>
+        <p:txBody>
+          <a:bodyPr wrap="square" lIns="0" tIns="0" rIns="0" bIns="0" rtlCol="0" anchor="ctr"/>
+          <a:lstStyle/>
+          <a:p>
+            <a:pPr indent="0" marL="0">
+              <a:buNone/>
+            </a:pPr>
+            <a:r>
+              <a:rPr lang="en-US" sz="3300" b="1" dirty="0">
+                <a:solidFill>
+                  <a:srgbClr val="FFFFFF"/>
+                </a:solidFill>
+                <a:latin typeface="Calibri" pitchFamily="34" charset="0"/>
+                <a:ea typeface="Calibri" pitchFamily="34" charset="-122"/>
+                <a:cs typeface="Calibri" pitchFamily="34" charset="-120"/>
+              </a:rPr>
+              <a:t>RESERVA TU PRIVADO</a:t>
+            </a:r>
+            <a:endParaRPr lang="en-US" sz="3300" dirty="0"/>
+          </a:p>
+        </p:txBody>
+      </p:sp>
+      <p:sp>
+        <p:nvSpPr>
+          <p:cNvPr id="9" name="Shape 7"/>
+          <p:cNvSpPr/>
+          <p:nvPr/>
+        </p:nvSpPr>
+        <p:spPr>
+          <a:xfrm>
+            <a:off x="548640" y="9098280"/>
+            <a:ext cx="5760720" cy="1783080"/>
           </a:xfrm>
           <a:prstGeom prst="roundRect">
             <a:avLst>
-              <a:gd name="adj" fmla="val 5217"/>
+              <a:gd name="adj" fmla="val 6154"/>
             </a:avLst>
           </a:prstGeom>
           <a:solidFill>
@@ -2854,13 +2640,13 @@
       </p:sp>
       <p:sp>
         <p:nvSpPr>
-          <p:cNvPr id="9" name="Text 7"/>
-          <p:cNvSpPr/>
-          <p:nvPr/>
-        </p:nvSpPr>
-        <p:spPr>
-          <a:xfrm>
-            <a:off x="868680" y="8641080"/>
+          <p:cNvPr id="10" name="Text 8"/>
+          <p:cNvSpPr/>
+          <p:nvPr/>
+        </p:nvSpPr>
+        <p:spPr>
+          <a:xfrm>
+            <a:off x="868680" y="9281160"/>
             <a:ext cx="2743200" cy="274320"/>
           </a:xfrm>
           <a:prstGeom prst="rect">
@@ -2893,14 +2679,14 @@
       </p:sp>
       <p:sp>
         <p:nvSpPr>
-          <p:cNvPr id="10" name="Text 8"/>
-          <p:cNvSpPr/>
-          <p:nvPr/>
-        </p:nvSpPr>
-        <p:spPr>
-          <a:xfrm>
-            <a:off x="868680" y="8869680"/>
-            <a:ext cx="1371600" cy="1188720"/>
+          <p:cNvPr id="11" name="Text 9"/>
+          <p:cNvSpPr/>
+          <p:nvPr/>
+        </p:nvSpPr>
+        <p:spPr>
+          <a:xfrm>
+            <a:off x="868680" y="9509760"/>
+            <a:ext cx="1280160" cy="1097280"/>
           </a:xfrm>
           <a:prstGeom prst="rect">
             <a:avLst/>
@@ -2916,7 +2702,7 @@
               <a:buNone/>
             </a:pPr>
             <a:r>
-              <a:rPr lang="en-US" sz="7600" b="1" dirty="0">
+              <a:rPr lang="en-US" sz="6800" b="1" dirty="0">
                 <a:solidFill>
                   <a:srgbClr val="FFFFFF"/>
                 </a:solidFill>
@@ -2926,19 +2712,19 @@
               </a:rPr>
               <a:t>2</a:t>
             </a:r>
-            <a:endParaRPr lang="en-US" sz="7600" dirty="0"/>
-          </a:p>
-        </p:txBody>
-      </p:sp>
-      <p:sp>
-        <p:nvSpPr>
-          <p:cNvPr id="11" name="Text 9"/>
-          <p:cNvSpPr/>
-          <p:nvPr/>
-        </p:nvSpPr>
-        <p:spPr>
-          <a:xfrm>
-            <a:off x="2194560" y="9235440"/>
+            <a:endParaRPr lang="en-US" sz="6800" dirty="0"/>
+          </a:p>
+        </p:txBody>
+      </p:sp>
+      <p:sp>
+        <p:nvSpPr>
+          <p:cNvPr id="12" name="Text 10"/>
+          <p:cNvSpPr/>
+          <p:nvPr/>
+        </p:nvSpPr>
+        <p:spPr>
+          <a:xfrm>
+            <a:off x="2103120" y="9802368"/>
             <a:ext cx="2743200" cy="457200"/>
           </a:xfrm>
           <a:prstGeom prst="rect">
@@ -2971,14 +2757,14 @@
       </p:sp>
       <p:sp>
         <p:nvSpPr>
-          <p:cNvPr id="12" name="Text 10"/>
-          <p:cNvSpPr/>
-          <p:nvPr/>
-        </p:nvSpPr>
-        <p:spPr>
-          <a:xfrm>
-            <a:off x="2194560" y="9692640"/>
-            <a:ext cx="3200400" cy="320040"/>
+          <p:cNvPr id="13" name="Text 11"/>
+          <p:cNvSpPr/>
+          <p:nvPr/>
+        </p:nvSpPr>
+        <p:spPr>
+          <a:xfrm>
+            <a:off x="2103120" y="10222992"/>
+            <a:ext cx="3657600" cy="320040"/>
           </a:xfrm>
           <a:prstGeom prst="rect">
             <a:avLst/>
@@ -3002,7 +2788,7 @@
                 <a:ea typeface="Calibri" pitchFamily="34" charset="-122"/>
                 <a:cs typeface="Calibri" pitchFamily="34" charset="-120"/>
               </a:rPr>
-              <a:t>para el [día]</a:t>
+              <a:t>para el [día / fecha]</a:t>
             </a:r>
             <a:endParaRPr lang="en-US" sz="1600" dirty="0"/>
           </a:p>
@@ -3010,14 +2796,14 @@
       </p:sp>
       <p:sp>
         <p:nvSpPr>
-          <p:cNvPr id="13" name="Text 11"/>
-          <p:cNvSpPr/>
-          <p:nvPr/>
-        </p:nvSpPr>
-        <p:spPr>
-          <a:xfrm>
-            <a:off x="868680" y="10104120"/>
-            <a:ext cx="5120640" cy="274320"/>
+          <p:cNvPr id="14" name="Text 12"/>
+          <p:cNvSpPr/>
+          <p:nvPr/>
+        </p:nvSpPr>
+        <p:spPr>
+          <a:xfrm>
+            <a:off x="868680" y="10561320"/>
+            <a:ext cx="5120640" cy="256032"/>
           </a:xfrm>
           <a:prstGeom prst="rect">
             <a:avLst/>
@@ -3041,7 +2827,7 @@
                 <a:ea typeface="Calibri" pitchFamily="34" charset="-122"/>
                 <a:cs typeface="Calibri" pitchFamily="34" charset="-120"/>
               </a:rPr>
-              <a:t>Cupo limitado por noche · Se aparta con anticipo</a:t>
+              <a:t>Cupo limitado por noche</a:t>
             </a:r>
             <a:endParaRPr lang="en-US" sz="1200" dirty="0"/>
           </a:p>
@@ -3049,13 +2835,13 @@
       </p:sp>
       <p:sp>
         <p:nvSpPr>
-          <p:cNvPr id="14" name="Shape 12"/>
-          <p:cNvSpPr/>
-          <p:nvPr/>
-        </p:nvSpPr>
-        <p:spPr>
-          <a:xfrm>
-            <a:off x="548640" y="10789920"/>
+          <p:cNvPr id="15" name="Shape 13"/>
+          <p:cNvSpPr/>
+          <p:nvPr/>
+        </p:nvSpPr>
+        <p:spPr>
+          <a:xfrm>
+            <a:off x="548640" y="11155680"/>
             <a:ext cx="5760720" cy="685800"/>
           </a:xfrm>
           <a:prstGeom prst="roundRect">
@@ -3076,13 +2862,13 @@
       </p:sp>
       <p:sp>
         <p:nvSpPr>
-          <p:cNvPr id="15" name="Text 13"/>
-          <p:cNvSpPr/>
-          <p:nvPr/>
-        </p:nvSpPr>
-        <p:spPr>
-          <a:xfrm>
-            <a:off x="548640" y="10789920"/>
+          <p:cNvPr id="16" name="Text 14"/>
+          <p:cNvSpPr/>
+          <p:nvPr/>
+        </p:nvSpPr>
+        <p:spPr>
+          <a:xfrm>
+            <a:off x="548640" y="11155680"/>
             <a:ext cx="5760720" cy="685800"/>
           </a:xfrm>
           <a:prstGeom prst="rect">
@@ -3107,7 +2893,7 @@
                 <a:ea typeface="Calibri" pitchFamily="34" charset="-122"/>
                 <a:cs typeface="Calibri" pitchFamily="34" charset="-120"/>
               </a:rPr>
-              <a:t>Reserva el tuyo 👉 WhatsApp</a:t>
+              <a:t>Aparta el tuyo 👉 WhatsApp</a:t>
             </a:r>
             <a:endParaRPr lang="en-US" sz="1700" dirty="0"/>
           </a:p>

</xml_diff>